<commit_message>
Demo fixtures: S7 editor pane (Geoff, 2026-10-11): three sends in the Auto-add decision chat after S5, each with its file before and after: the PRD's What we heard by Send Selection (s7/prd-v2.before/after.md), the prototype's new Fix button by the element picker (s7/scan-review.after.html), and a new paragraph slide 3 by the shape picker, turned into three bullets (s7/team-review-oct15.after.pptx, byte-stable); payloads in SendFormat's own form
Co-Authored-By: Claude Opus 5.5 <noreply@anthropic.com>
Claude-Session: https://claude.ai/code/session_01T7qxTYsSVreoCbVkvqVb6X
</commit_message>
<xml_diff>
--- a/video/fixture/docs/docs/team-review-oct15.pptx
+++ b/video/fixture/docs/docs/team-review-oct15.pptx
@@ -11,6 +11,7 @@
     <p:sldId id="259" r:id="rId10"/>
     <p:sldId id="260" r:id="rId11"/>
     <p:sldId id="261" r:id="rId12"/>
+    <p:sldId id="262" r:id="rId13"/>
   </p:sldIdLst>
   <p:sldSz cx="12191695" cy="6858000" type="screen4x3"/>
   <p:notesSz cx="6858000" cy="9144000"/>
@@ -3923,7 +3924,7 @@
                 </a:solidFill>
                 <a:latin typeface="Georgia"/>
               </a:rPr>
-              <a:t>What we heard from testers</a:t>
+              <a:t>What the eval found</a:t>
             </a:r>
           </a:p>
         </p:txBody>
@@ -4044,23 +4045,62 @@
       </p:sp>
       <p:sp>
         <p:nvSpPr>
-          <p:cNvPr id="7" name="Rectangle 6"/>
-          <p:cNvSpPr/>
+          <p:cNvPr id="7" name="TextBox 6"/>
+          <p:cNvSpPr txBox="1"/>
           <p:nvPr/>
         </p:nvSpPr>
         <p:spPr>
           <a:xfrm>
-            <a:off x="731520" y="1783080"/>
-            <a:ext cx="73152" cy="1234440"/>
+            <a:off x="822960" y="1920240"/>
+            <a:ext cx="7040880" cy="4023360"/>
           </a:xfrm>
           <a:prstGeom prst="rect">
             <a:avLst/>
           </a:prstGeom>
+          <a:noFill/>
+        </p:spPr>
+        <p:txBody>
+          <a:bodyPr wrap="square" anchor="t">
+            <a:spAutoFit/>
+          </a:bodyPr>
+          <a:lstStyle/>
+          <a:p>
+            <a:pPr algn="l"/>
+            <a:r>
+              <a:rPr sz="2400" b="0">
+                <a:solidFill>
+                  <a:srgbClr val="242B28"/>
+                </a:solidFill>
+                <a:latin typeface="Georgia"/>
+              </a:rPr>
+              <a:t>Ravi's Sep 28 eval read 81% of spines right across 1,240 photos from 96 shelves. Tilted spines caused 34% of the wrong reads and glare 27%, most of it at glass-door boxes. With a review step in the prototype, testers got 97% of books right in a median 18 seconds a shelf.</a:t>
+            </a:r>
+          </a:p>
+        </p:txBody>
+      </p:sp>
+      <p:sp>
+        <p:nvSpPr>
+          <p:cNvPr id="8" name="Rounded Rectangle 7"/>
+          <p:cNvSpPr/>
+          <p:nvPr/>
+        </p:nvSpPr>
+        <p:spPr>
+          <a:xfrm>
+            <a:off x="8229600" y="2011680"/>
+            <a:ext cx="3383280" cy="3200400"/>
+          </a:xfrm>
+          <a:prstGeom prst="roundRect">
+            <a:avLst>
+              <a:gd name="adj" fmla="val 5000"/>
+            </a:avLst>
+          </a:prstGeom>
           <a:solidFill>
-            <a:srgbClr val="0F5C4D"/>
+            <a:srgbClr val="FFFDF8"/>
           </a:solidFill>
           <a:ln>
-            <a:noFill/>
+            <a:solidFill>
+              <a:srgbClr val="DDD5C2"/>
+            </a:solidFill>
           </a:ln>
           <a:effectLst/>
         </p:spPr>
@@ -4088,14 +4128,14 @@
       </p:sp>
       <p:sp>
         <p:nvSpPr>
-          <p:cNvPr id="8" name="TextBox 7"/>
+          <p:cNvPr id="9" name="TextBox 8"/>
           <p:cNvSpPr txBox="1"/>
           <p:nvPr/>
         </p:nvSpPr>
         <p:spPr>
           <a:xfrm>
-            <a:off x="1005840" y="1737360"/>
-            <a:ext cx="6675120" cy="914400"/>
+            <a:off x="8366760" y="2286000"/>
+            <a:ext cx="3108960" cy="1097280"/>
           </a:xfrm>
           <a:prstGeom prst="rect">
             <a:avLst/>
@@ -4108,254 +4148,22 @@
           </a:bodyPr>
           <a:lstStyle/>
           <a:p>
-            <a:pPr algn="l"/>
-            <a:r>
-              <a:rPr sz="2600" b="0">
-                <a:solidFill>
-                  <a:srgbClr val="242B28"/>
-                </a:solidFill>
-                <a:latin typeface="Georgia"/>
-              </a:rPr>
-              <a:t>“My own box has a book on it that isn’t there.”</a:t>
-            </a:r>
-          </a:p>
-        </p:txBody>
-      </p:sp>
-      <p:sp>
-        <p:nvSpPr>
-          <p:cNvPr id="9" name="TextBox 8"/>
-          <p:cNvSpPr txBox="1"/>
-          <p:nvPr/>
-        </p:nvSpPr>
-        <p:spPr>
-          <a:xfrm>
-            <a:off x="1005840" y="2651760"/>
-            <a:ext cx="6675120" cy="365760"/>
-          </a:xfrm>
-          <a:prstGeom prst="rect">
-            <a:avLst/>
-          </a:prstGeom>
-          <a:noFill/>
-        </p:spPr>
-        <p:txBody>
-          <a:bodyPr wrap="square" anchor="t">
-            <a:spAutoFit/>
-          </a:bodyPr>
-          <a:lstStyle/>
-          <a:p>
-            <a:pPr algn="l"/>
-            <a:r>
-              <a:rPr sz="1600" b="0">
-                <a:solidFill>
-                  <a:srgbClr val="6E726A"/>
-                </a:solidFill>
-                <a:latin typeface="Helvetica Neue"/>
-              </a:rPr>
-              <a:t>Denise, P3</a:t>
-            </a:r>
-          </a:p>
-        </p:txBody>
-      </p:sp>
-      <p:sp>
-        <p:nvSpPr>
-          <p:cNvPr id="10" name="Rectangle 9"/>
-          <p:cNvSpPr/>
-          <p:nvPr/>
-        </p:nvSpPr>
-        <p:spPr>
-          <a:xfrm>
-            <a:off x="731520" y="3566160"/>
-            <a:ext cx="73152" cy="1234440"/>
-          </a:xfrm>
-          <a:prstGeom prst="rect">
-            <a:avLst/>
-          </a:prstGeom>
-          <a:solidFill>
-            <a:srgbClr val="0F5C4D"/>
-          </a:solidFill>
-          <a:ln>
-            <a:noFill/>
-          </a:ln>
-          <a:effectLst/>
-        </p:spPr>
-        <p:style>
-          <a:lnRef idx="1">
-            <a:schemeClr val="accent1"/>
-          </a:lnRef>
-          <a:fillRef idx="3">
-            <a:schemeClr val="accent1"/>
-          </a:fillRef>
-          <a:effectRef idx="2">
-            <a:schemeClr val="accent1"/>
-          </a:effectRef>
-          <a:fontRef idx="minor">
-            <a:schemeClr val="lt1"/>
-          </a:fontRef>
-        </p:style>
-        <p:txBody>
-          <a:bodyPr rtlCol="0" anchor="ctr"/>
-          <a:lstStyle/>
-          <a:p>
             <a:pPr algn="ctr"/>
-          </a:p>
-        </p:txBody>
-      </p:sp>
-      <p:sp>
-        <p:nvSpPr>
-          <p:cNvPr id="11" name="TextBox 10"/>
-          <p:cNvSpPr txBox="1"/>
-          <p:nvPr/>
-        </p:nvSpPr>
-        <p:spPr>
-          <a:xfrm>
-            <a:off x="1005840" y="3520440"/>
-            <a:ext cx="6675120" cy="914400"/>
-          </a:xfrm>
-          <a:prstGeom prst="rect">
-            <a:avLst/>
-          </a:prstGeom>
-          <a:noFill/>
-        </p:spPr>
-        <p:txBody>
-          <a:bodyPr wrap="square" anchor="t">
-            <a:spAutoFit/>
-          </a:bodyPr>
-          <a:lstStyle/>
-          <a:p>
-            <a:pPr algn="l"/>
-            <a:r>
-              <a:rPr sz="2600" b="0">
-                <a:solidFill>
-                  <a:srgbClr val="242B28"/>
-                </a:solidFill>
-                <a:latin typeface="Georgia"/>
-              </a:rPr>
-              <a:t>“Two wrong books and I stopped.”</a:t>
-            </a:r>
-          </a:p>
-        </p:txBody>
-      </p:sp>
-      <p:sp>
-        <p:nvSpPr>
-          <p:cNvPr id="12" name="TextBox 11"/>
-          <p:cNvSpPr txBox="1"/>
-          <p:nvPr/>
-        </p:nvSpPr>
-        <p:spPr>
-          <a:xfrm>
-            <a:off x="1005840" y="4434840"/>
-            <a:ext cx="6675120" cy="365760"/>
-          </a:xfrm>
-          <a:prstGeom prst="rect">
-            <a:avLst/>
-          </a:prstGeom>
-          <a:noFill/>
-        </p:spPr>
-        <p:txBody>
-          <a:bodyPr wrap="square" anchor="t">
-            <a:spAutoFit/>
-          </a:bodyPr>
-          <a:lstStyle/>
-          <a:p>
-            <a:pPr algn="l"/>
-            <a:r>
-              <a:rPr sz="1600" b="0">
-                <a:solidFill>
-                  <a:srgbClr val="6E726A"/>
-                </a:solidFill>
-                <a:latin typeface="Helvetica Neue"/>
-              </a:rPr>
-              <a:t>Owen, P8</a:t>
-            </a:r>
-          </a:p>
-        </p:txBody>
-      </p:sp>
-      <p:sp>
-        <p:nvSpPr>
-          <p:cNvPr id="13" name="Rounded Rectangle 12"/>
-          <p:cNvSpPr/>
-          <p:nvPr/>
-        </p:nvSpPr>
-        <p:spPr>
-          <a:xfrm>
-            <a:off x="8229600" y="2011680"/>
-            <a:ext cx="3383280" cy="3200400"/>
-          </a:xfrm>
-          <a:prstGeom prst="roundRect">
-            <a:avLst>
-              <a:gd name="adj" fmla="val 5000"/>
-            </a:avLst>
-          </a:prstGeom>
-          <a:solidFill>
-            <a:srgbClr val="FFFDF8"/>
-          </a:solidFill>
-          <a:ln>
-            <a:solidFill>
-              <a:srgbClr val="DDD5C2"/>
-            </a:solidFill>
-          </a:ln>
-          <a:effectLst/>
-        </p:spPr>
-        <p:style>
-          <a:lnRef idx="1">
-            <a:schemeClr val="accent1"/>
-          </a:lnRef>
-          <a:fillRef idx="3">
-            <a:schemeClr val="accent1"/>
-          </a:fillRef>
-          <a:effectRef idx="2">
-            <a:schemeClr val="accent1"/>
-          </a:effectRef>
-          <a:fontRef idx="minor">
-            <a:schemeClr val="lt1"/>
-          </a:fontRef>
-        </p:style>
-        <p:txBody>
-          <a:bodyPr rtlCol="0" anchor="ctr"/>
-          <a:lstStyle/>
-          <a:p>
-            <a:pPr algn="ctr"/>
-          </a:p>
-        </p:txBody>
-      </p:sp>
-      <p:sp>
-        <p:nvSpPr>
-          <p:cNvPr id="14" name="TextBox 13"/>
-          <p:cNvSpPr txBox="1"/>
-          <p:nvPr/>
-        </p:nvSpPr>
-        <p:spPr>
-          <a:xfrm>
-            <a:off x="8366760" y="2286000"/>
-            <a:ext cx="3108960" cy="1097280"/>
-          </a:xfrm>
-          <a:prstGeom prst="rect">
-            <a:avLst/>
-          </a:prstGeom>
-          <a:noFill/>
-        </p:spPr>
-        <p:txBody>
-          <a:bodyPr wrap="square" anchor="t">
-            <a:spAutoFit/>
-          </a:bodyPr>
-          <a:lstStyle/>
-          <a:p>
-            <a:pPr algn="ctr"/>
-            <a:r>
-              <a:rPr sz="4800" b="1">
+            <a:r>
+              <a:rPr sz="5400" b="1">
                 <a:solidFill>
                   <a:srgbClr val="0F5C4D"/>
                 </a:solidFill>
                 <a:latin typeface="Georgia"/>
               </a:rPr>
-              <a:t>46 of 148</a:t>
-            </a:r>
-          </a:p>
-        </p:txBody>
-      </p:sp>
-      <p:sp>
-        <p:nvSpPr>
-          <p:cNvPr id="15" name="TextBox 14"/>
+              <a:t>236</a:t>
+            </a:r>
+          </a:p>
+        </p:txBody>
+      </p:sp>
+      <p:sp>
+        <p:nvSpPr>
+          <p:cNvPr id="10" name="TextBox 9"/>
           <p:cNvSpPr txBox="1"/>
           <p:nvPr/>
         </p:nvSpPr>
@@ -4383,7 +4191,7 @@
                 </a:solidFill>
                 <a:latin typeface="Helvetica Neue"/>
               </a:rPr>
-              <a:t>testers who saw a wrong book stopped scanning</a:t>
+              <a:t>wrong reads in 1,240 photos</a:t>
             </a:r>
           </a:p>
         </p:txBody>
@@ -4488,7 +4296,7 @@
                 </a:solidFill>
                 <a:latin typeface="Georgia"/>
               </a:rPr>
-              <a:t>Proposal: review before add</a:t>
+              <a:t>What we heard from testers</a:t>
             </a:r>
           </a:p>
         </p:txBody>
@@ -4609,14 +4417,58 @@
       </p:sp>
       <p:sp>
         <p:nvSpPr>
-          <p:cNvPr id="7" name="TextBox 6"/>
+          <p:cNvPr id="7" name="Rectangle 6"/>
+          <p:cNvSpPr/>
+          <p:nvPr/>
+        </p:nvSpPr>
+        <p:spPr>
+          <a:xfrm>
+            <a:off x="731520" y="1783080"/>
+            <a:ext cx="73152" cy="1234440"/>
+          </a:xfrm>
+          <a:prstGeom prst="rect">
+            <a:avLst/>
+          </a:prstGeom>
+          <a:solidFill>
+            <a:srgbClr val="0F5C4D"/>
+          </a:solidFill>
+          <a:ln>
+            <a:noFill/>
+          </a:ln>
+          <a:effectLst/>
+        </p:spPr>
+        <p:style>
+          <a:lnRef idx="1">
+            <a:schemeClr val="accent1"/>
+          </a:lnRef>
+          <a:fillRef idx="3">
+            <a:schemeClr val="accent1"/>
+          </a:fillRef>
+          <a:effectRef idx="2">
+            <a:schemeClr val="accent1"/>
+          </a:effectRef>
+          <a:fontRef idx="minor">
+            <a:schemeClr val="lt1"/>
+          </a:fontRef>
+        </p:style>
+        <p:txBody>
+          <a:bodyPr rtlCol="0" anchor="ctr"/>
+          <a:lstStyle/>
+          <a:p>
+            <a:pPr algn="ctr"/>
+          </a:p>
+        </p:txBody>
+      </p:sp>
+      <p:sp>
+        <p:nvSpPr>
+          <p:cNvPr id="8" name="TextBox 7"/>
           <p:cNvSpPr txBox="1"/>
           <p:nvPr/>
         </p:nvSpPr>
         <p:spPr>
           <a:xfrm>
-            <a:off x="822960" y="1920240"/>
-            <a:ext cx="10424160" cy="4114800"/>
+            <a:off x="1005840" y="1737360"/>
+            <a:ext cx="6675120" cy="914400"/>
           </a:xfrm>
           <a:prstGeom prst="rect">
             <a:avLst/>
@@ -4624,88 +4476,287 @@
           <a:noFill/>
         </p:spPr>
         <p:txBody>
-          <a:bodyPr wrap="square">
+          <a:bodyPr wrap="square" anchor="t">
             <a:spAutoFit/>
           </a:bodyPr>
           <a:lstStyle/>
           <a:p>
-            <a:pPr>
-              <a:spcAft>
-                <a:spcPts val="1800"/>
-              </a:spcAft>
-            </a:pPr>
-            <a:r>
-              <a:rPr sz="3000">
+            <a:pPr algn="l"/>
+            <a:r>
+              <a:rPr sz="2600" b="0">
                 <a:solidFill>
                   <a:srgbClr val="242B28"/>
                 </a:solidFill>
                 <a:latin typeface="Georgia"/>
               </a:rPr>
-              <a:t>•  Show every spine the scan found</a:t>
-            </a:r>
-          </a:p>
-          <a:p>
-            <a:pPr>
-              <a:spcAft>
-                <a:spcPts val="1800"/>
-              </a:spcAft>
-            </a:pPr>
-            <a:r>
-              <a:rPr sz="3000">
+              <a:t>“My own box has a book on it that isn’t there.”</a:t>
+            </a:r>
+          </a:p>
+        </p:txBody>
+      </p:sp>
+      <p:sp>
+        <p:nvSpPr>
+          <p:cNvPr id="9" name="TextBox 8"/>
+          <p:cNvSpPr txBox="1"/>
+          <p:nvPr/>
+        </p:nvSpPr>
+        <p:spPr>
+          <a:xfrm>
+            <a:off x="1005840" y="2651760"/>
+            <a:ext cx="6675120" cy="365760"/>
+          </a:xfrm>
+          <a:prstGeom prst="rect">
+            <a:avLst/>
+          </a:prstGeom>
+          <a:noFill/>
+        </p:spPr>
+        <p:txBody>
+          <a:bodyPr wrap="square" anchor="t">
+            <a:spAutoFit/>
+          </a:bodyPr>
+          <a:lstStyle/>
+          <a:p>
+            <a:pPr algn="l"/>
+            <a:r>
+              <a:rPr sz="1600" b="0">
+                <a:solidFill>
+                  <a:srgbClr val="6E726A"/>
+                </a:solidFill>
+                <a:latin typeface="Helvetica Neue"/>
+              </a:rPr>
+              <a:t>Denise, P3</a:t>
+            </a:r>
+          </a:p>
+        </p:txBody>
+      </p:sp>
+      <p:sp>
+        <p:nvSpPr>
+          <p:cNvPr id="10" name="Rectangle 9"/>
+          <p:cNvSpPr/>
+          <p:nvPr/>
+        </p:nvSpPr>
+        <p:spPr>
+          <a:xfrm>
+            <a:off x="731520" y="3566160"/>
+            <a:ext cx="73152" cy="1234440"/>
+          </a:xfrm>
+          <a:prstGeom prst="rect">
+            <a:avLst/>
+          </a:prstGeom>
+          <a:solidFill>
+            <a:srgbClr val="0F5C4D"/>
+          </a:solidFill>
+          <a:ln>
+            <a:noFill/>
+          </a:ln>
+          <a:effectLst/>
+        </p:spPr>
+        <p:style>
+          <a:lnRef idx="1">
+            <a:schemeClr val="accent1"/>
+          </a:lnRef>
+          <a:fillRef idx="3">
+            <a:schemeClr val="accent1"/>
+          </a:fillRef>
+          <a:effectRef idx="2">
+            <a:schemeClr val="accent1"/>
+          </a:effectRef>
+          <a:fontRef idx="minor">
+            <a:schemeClr val="lt1"/>
+          </a:fontRef>
+        </p:style>
+        <p:txBody>
+          <a:bodyPr rtlCol="0" anchor="ctr"/>
+          <a:lstStyle/>
+          <a:p>
+            <a:pPr algn="ctr"/>
+          </a:p>
+        </p:txBody>
+      </p:sp>
+      <p:sp>
+        <p:nvSpPr>
+          <p:cNvPr id="11" name="TextBox 10"/>
+          <p:cNvSpPr txBox="1"/>
+          <p:nvPr/>
+        </p:nvSpPr>
+        <p:spPr>
+          <a:xfrm>
+            <a:off x="1005840" y="3520440"/>
+            <a:ext cx="6675120" cy="914400"/>
+          </a:xfrm>
+          <a:prstGeom prst="rect">
+            <a:avLst/>
+          </a:prstGeom>
+          <a:noFill/>
+        </p:spPr>
+        <p:txBody>
+          <a:bodyPr wrap="square" anchor="t">
+            <a:spAutoFit/>
+          </a:bodyPr>
+          <a:lstStyle/>
+          <a:p>
+            <a:pPr algn="l"/>
+            <a:r>
+              <a:rPr sz="2600" b="0">
                 <a:solidFill>
                   <a:srgbClr val="242B28"/>
                 </a:solidFill>
                 <a:latin typeface="Georgia"/>
               </a:rPr>
-              <a:t>•  Flag the ones the model is unsure of</a:t>
-            </a:r>
-          </a:p>
-          <a:p>
-            <a:pPr>
-              <a:spcAft>
-                <a:spcPts val="1800"/>
-              </a:spcAft>
-            </a:pPr>
-            <a:r>
-              <a:rPr sz="3000">
+              <a:t>“Two wrong books and I stopped.”</a:t>
+            </a:r>
+          </a:p>
+        </p:txBody>
+      </p:sp>
+      <p:sp>
+        <p:nvSpPr>
+          <p:cNvPr id="12" name="TextBox 11"/>
+          <p:cNvSpPr txBox="1"/>
+          <p:nvPr/>
+        </p:nvSpPr>
+        <p:spPr>
+          <a:xfrm>
+            <a:off x="1005840" y="4434840"/>
+            <a:ext cx="6675120" cy="365760"/>
+          </a:xfrm>
+          <a:prstGeom prst="rect">
+            <a:avLst/>
+          </a:prstGeom>
+          <a:noFill/>
+        </p:spPr>
+        <p:txBody>
+          <a:bodyPr wrap="square" anchor="t">
+            <a:spAutoFit/>
+          </a:bodyPr>
+          <a:lstStyle/>
+          <a:p>
+            <a:pPr algn="l"/>
+            <a:r>
+              <a:rPr sz="1600" b="0">
+                <a:solidFill>
+                  <a:srgbClr val="6E726A"/>
+                </a:solidFill>
+                <a:latin typeface="Helvetica Neue"/>
+              </a:rPr>
+              <a:t>Owen, P8</a:t>
+            </a:r>
+          </a:p>
+        </p:txBody>
+      </p:sp>
+      <p:sp>
+        <p:nvSpPr>
+          <p:cNvPr id="13" name="Rounded Rectangle 12"/>
+          <p:cNvSpPr/>
+          <p:nvPr/>
+        </p:nvSpPr>
+        <p:spPr>
+          <a:xfrm>
+            <a:off x="8229600" y="2011680"/>
+            <a:ext cx="3383280" cy="3200400"/>
+          </a:xfrm>
+          <a:prstGeom prst="roundRect">
+            <a:avLst>
+              <a:gd name="adj" fmla="val 5000"/>
+            </a:avLst>
+          </a:prstGeom>
+          <a:solidFill>
+            <a:srgbClr val="FFFDF8"/>
+          </a:solidFill>
+          <a:ln>
+            <a:solidFill>
+              <a:srgbClr val="DDD5C2"/>
+            </a:solidFill>
+          </a:ln>
+          <a:effectLst/>
+        </p:spPr>
+        <p:style>
+          <a:lnRef idx="1">
+            <a:schemeClr val="accent1"/>
+          </a:lnRef>
+          <a:fillRef idx="3">
+            <a:schemeClr val="accent1"/>
+          </a:fillRef>
+          <a:effectRef idx="2">
+            <a:schemeClr val="accent1"/>
+          </a:effectRef>
+          <a:fontRef idx="minor">
+            <a:schemeClr val="lt1"/>
+          </a:fontRef>
+        </p:style>
+        <p:txBody>
+          <a:bodyPr rtlCol="0" anchor="ctr"/>
+          <a:lstStyle/>
+          <a:p>
+            <a:pPr algn="ctr"/>
+          </a:p>
+        </p:txBody>
+      </p:sp>
+      <p:sp>
+        <p:nvSpPr>
+          <p:cNvPr id="14" name="TextBox 13"/>
+          <p:cNvSpPr txBox="1"/>
+          <p:nvPr/>
+        </p:nvSpPr>
+        <p:spPr>
+          <a:xfrm>
+            <a:off x="8366760" y="2286000"/>
+            <a:ext cx="3108960" cy="1097280"/>
+          </a:xfrm>
+          <a:prstGeom prst="rect">
+            <a:avLst/>
+          </a:prstGeom>
+          <a:noFill/>
+        </p:spPr>
+        <p:txBody>
+          <a:bodyPr wrap="square" anchor="t">
+            <a:spAutoFit/>
+          </a:bodyPr>
+          <a:lstStyle/>
+          <a:p>
+            <a:pPr algn="ctr"/>
+            <a:r>
+              <a:rPr sz="4800" b="1">
+                <a:solidFill>
+                  <a:srgbClr val="0F5C4D"/>
+                </a:solidFill>
+                <a:latin typeface="Georgia"/>
+              </a:rPr>
+              <a:t>46 of 148</a:t>
+            </a:r>
+          </a:p>
+        </p:txBody>
+      </p:sp>
+      <p:sp>
+        <p:nvSpPr>
+          <p:cNvPr id="15" name="TextBox 14"/>
+          <p:cNvSpPr txBox="1"/>
+          <p:nvPr/>
+        </p:nvSpPr>
+        <p:spPr>
+          <a:xfrm>
+            <a:off x="8503920" y="3566160"/>
+            <a:ext cx="2834640" cy="1371600"/>
+          </a:xfrm>
+          <a:prstGeom prst="rect">
+            <a:avLst/>
+          </a:prstGeom>
+          <a:noFill/>
+        </p:spPr>
+        <p:txBody>
+          <a:bodyPr wrap="square" anchor="t">
+            <a:spAutoFit/>
+          </a:bodyPr>
+          <a:lstStyle/>
+          <a:p>
+            <a:pPr algn="ctr"/>
+            <a:r>
+              <a:rPr sz="1800" b="0">
                 <a:solidFill>
                   <a:srgbClr val="242B28"/>
                 </a:solidFill>
-                <a:latin typeface="Georgia"/>
+                <a:latin typeface="Helvetica Neue"/>
               </a:rPr>
-              <a:t>•  Fix a miss in one tap</a:t>
-            </a:r>
-          </a:p>
-          <a:p>
-            <a:pPr>
-              <a:spcAft>
-                <a:spcPts val="1800"/>
-              </a:spcAft>
-            </a:pPr>
-            <a:r>
-              <a:rPr sz="3000">
-                <a:solidFill>
-                  <a:srgbClr val="242B28"/>
-                </a:solidFill>
-                <a:latin typeface="Georgia"/>
-              </a:rPr>
-              <a:t>•  Nothing is added until you tap “Add”</a:t>
-            </a:r>
-          </a:p>
-          <a:p>
-            <a:pPr>
-              <a:spcAft>
-                <a:spcPts val="1800"/>
-              </a:spcAft>
-            </a:pPr>
-            <a:r>
-              <a:rPr sz="3000">
-                <a:solidFill>
-                  <a:srgbClr val="242B28"/>
-                </a:solidFill>
-                <a:latin typeface="Georgia"/>
-              </a:rPr>
-              <a:t>•  Warn about glare before the photo</a:t>
+              <a:t>testers who saw a wrong book stopped scanning</a:t>
             </a:r>
           </a:p>
         </p:txBody>
@@ -4810,7 +4861,7 @@
                 </a:solidFill>
                 <a:latin typeface="Georgia"/>
               </a:rPr>
-              <a:t>Targets</a:t>
+              <a:t>Proposal: review before add</a:t>
             </a:r>
           </a:p>
         </p:txBody>
@@ -4925,6 +4976,328 @@
                 <a:latin typeface="Helvetica Neue"/>
               </a:rPr>
               <a:t>5</a:t>
+            </a:r>
+          </a:p>
+        </p:txBody>
+      </p:sp>
+      <p:sp>
+        <p:nvSpPr>
+          <p:cNvPr id="7" name="TextBox 6"/>
+          <p:cNvSpPr txBox="1"/>
+          <p:nvPr/>
+        </p:nvSpPr>
+        <p:spPr>
+          <a:xfrm>
+            <a:off x="822960" y="1920240"/>
+            <a:ext cx="10424160" cy="4114800"/>
+          </a:xfrm>
+          <a:prstGeom prst="rect">
+            <a:avLst/>
+          </a:prstGeom>
+          <a:noFill/>
+        </p:spPr>
+        <p:txBody>
+          <a:bodyPr wrap="square">
+            <a:spAutoFit/>
+          </a:bodyPr>
+          <a:lstStyle/>
+          <a:p>
+            <a:pPr>
+              <a:spcAft>
+                <a:spcPts val="1800"/>
+              </a:spcAft>
+            </a:pPr>
+            <a:r>
+              <a:rPr sz="3000">
+                <a:solidFill>
+                  <a:srgbClr val="242B28"/>
+                </a:solidFill>
+                <a:latin typeface="Georgia"/>
+              </a:rPr>
+              <a:t>•  Show every spine the scan found</a:t>
+            </a:r>
+          </a:p>
+          <a:p>
+            <a:pPr>
+              <a:spcAft>
+                <a:spcPts val="1800"/>
+              </a:spcAft>
+            </a:pPr>
+            <a:r>
+              <a:rPr sz="3000">
+                <a:solidFill>
+                  <a:srgbClr val="242B28"/>
+                </a:solidFill>
+                <a:latin typeface="Georgia"/>
+              </a:rPr>
+              <a:t>•  Flag the ones the model is unsure of</a:t>
+            </a:r>
+          </a:p>
+          <a:p>
+            <a:pPr>
+              <a:spcAft>
+                <a:spcPts val="1800"/>
+              </a:spcAft>
+            </a:pPr>
+            <a:r>
+              <a:rPr sz="3000">
+                <a:solidFill>
+                  <a:srgbClr val="242B28"/>
+                </a:solidFill>
+                <a:latin typeface="Georgia"/>
+              </a:rPr>
+              <a:t>•  Fix a miss in one tap</a:t>
+            </a:r>
+          </a:p>
+          <a:p>
+            <a:pPr>
+              <a:spcAft>
+                <a:spcPts val="1800"/>
+              </a:spcAft>
+            </a:pPr>
+            <a:r>
+              <a:rPr sz="3000">
+                <a:solidFill>
+                  <a:srgbClr val="242B28"/>
+                </a:solidFill>
+                <a:latin typeface="Georgia"/>
+              </a:rPr>
+              <a:t>•  Nothing is added until you tap “Add”</a:t>
+            </a:r>
+          </a:p>
+          <a:p>
+            <a:pPr>
+              <a:spcAft>
+                <a:spcPts val="1800"/>
+              </a:spcAft>
+            </a:pPr>
+            <a:r>
+              <a:rPr sz="3000">
+                <a:solidFill>
+                  <a:srgbClr val="242B28"/>
+                </a:solidFill>
+                <a:latin typeface="Georgia"/>
+              </a:rPr>
+              <a:t>•  Warn about glare before the photo</a:t>
+            </a:r>
+          </a:p>
+        </p:txBody>
+      </p:sp>
+    </p:spTree>
+  </p:cSld>
+  <p:clrMapOvr>
+    <a:masterClrMapping/>
+  </p:clrMapOvr>
+</p:sld>
+</file>
+
+<file path=ppt/slides/slide6.xml><?xml version="1.0" encoding="utf-8"?>
+<p:sld xmlns:a="http://schemas.openxmlformats.org/drawingml/2006/main" xmlns:p="http://schemas.openxmlformats.org/presentationml/2006/main" xmlns:r="http://schemas.openxmlformats.org/officeDocument/2006/relationships">
+  <p:cSld>
+    <p:bg>
+      <p:bgPr>
+        <a:solidFill>
+          <a:srgbClr val="F6F1E6"/>
+        </a:solidFill>
+        <a:effectLst/>
+      </p:bgPr>
+    </p:bg>
+    <p:spTree>
+      <p:nvGrpSpPr>
+        <p:cNvPr id="1" name=""/>
+        <p:cNvGrpSpPr/>
+        <p:nvPr/>
+      </p:nvGrpSpPr>
+      <p:grpSpPr/>
+      <p:sp>
+        <p:nvSpPr>
+          <p:cNvPr id="2" name="Rectangle 1"/>
+          <p:cNvSpPr/>
+          <p:nvPr/>
+        </p:nvSpPr>
+        <p:spPr>
+          <a:xfrm>
+            <a:off x="0" y="0"/>
+            <a:ext cx="12191695" cy="164592"/>
+          </a:xfrm>
+          <a:prstGeom prst="rect">
+            <a:avLst/>
+          </a:prstGeom>
+          <a:solidFill>
+            <a:srgbClr val="0F5C4D"/>
+          </a:solidFill>
+          <a:ln>
+            <a:noFill/>
+          </a:ln>
+          <a:effectLst/>
+        </p:spPr>
+        <p:style>
+          <a:lnRef idx="1">
+            <a:schemeClr val="accent1"/>
+          </a:lnRef>
+          <a:fillRef idx="3">
+            <a:schemeClr val="accent1"/>
+          </a:fillRef>
+          <a:effectRef idx="2">
+            <a:schemeClr val="accent1"/>
+          </a:effectRef>
+          <a:fontRef idx="minor">
+            <a:schemeClr val="lt1"/>
+          </a:fontRef>
+        </p:style>
+        <p:txBody>
+          <a:bodyPr rtlCol="0" anchor="ctr"/>
+          <a:lstStyle/>
+          <a:p>
+            <a:pPr algn="ctr"/>
+          </a:p>
+        </p:txBody>
+      </p:sp>
+      <p:sp>
+        <p:nvSpPr>
+          <p:cNvPr id="3" name="TextBox 2"/>
+          <p:cNvSpPr txBox="1"/>
+          <p:nvPr/>
+        </p:nvSpPr>
+        <p:spPr>
+          <a:xfrm>
+            <a:off x="731520" y="502920"/>
+            <a:ext cx="10698480" cy="1097280"/>
+          </a:xfrm>
+          <a:prstGeom prst="rect">
+            <a:avLst/>
+          </a:prstGeom>
+          <a:noFill/>
+        </p:spPr>
+        <p:txBody>
+          <a:bodyPr wrap="square" anchor="ctr">
+            <a:spAutoFit/>
+          </a:bodyPr>
+          <a:lstStyle/>
+          <a:p>
+            <a:pPr algn="l"/>
+            <a:r>
+              <a:rPr sz="4000" b="1">
+                <a:solidFill>
+                  <a:srgbClr val="242B28"/>
+                </a:solidFill>
+                <a:latin typeface="Georgia"/>
+              </a:rPr>
+              <a:t>Targets</a:t>
+            </a:r>
+          </a:p>
+        </p:txBody>
+      </p:sp>
+      <p:sp>
+        <p:nvSpPr>
+          <p:cNvPr id="4" name="Rectangle 3"/>
+          <p:cNvSpPr/>
+          <p:nvPr/>
+        </p:nvSpPr>
+        <p:spPr>
+          <a:xfrm>
+            <a:off x="731520" y="6355080"/>
+            <a:ext cx="10725912" cy="18288"/>
+          </a:xfrm>
+          <a:prstGeom prst="rect">
+            <a:avLst/>
+          </a:prstGeom>
+          <a:solidFill>
+            <a:srgbClr val="DDD5C2"/>
+          </a:solidFill>
+          <a:ln>
+            <a:noFill/>
+          </a:ln>
+          <a:effectLst/>
+        </p:spPr>
+        <p:style>
+          <a:lnRef idx="1">
+            <a:schemeClr val="accent1"/>
+          </a:lnRef>
+          <a:fillRef idx="3">
+            <a:schemeClr val="accent1"/>
+          </a:fillRef>
+          <a:effectRef idx="2">
+            <a:schemeClr val="accent1"/>
+          </a:effectRef>
+          <a:fontRef idx="minor">
+            <a:schemeClr val="lt1"/>
+          </a:fontRef>
+        </p:style>
+        <p:txBody>
+          <a:bodyPr rtlCol="0" anchor="ctr"/>
+          <a:lstStyle/>
+          <a:p>
+            <a:pPr algn="ctr"/>
+          </a:p>
+        </p:txBody>
+      </p:sp>
+      <p:sp>
+        <p:nvSpPr>
+          <p:cNvPr id="5" name="TextBox 4"/>
+          <p:cNvSpPr txBox="1"/>
+          <p:nvPr/>
+        </p:nvSpPr>
+        <p:spPr>
+          <a:xfrm>
+            <a:off x="731520" y="6400800"/>
+            <a:ext cx="8229600" cy="274320"/>
+          </a:xfrm>
+          <a:prstGeom prst="rect">
+            <a:avLst/>
+          </a:prstGeom>
+          <a:noFill/>
+        </p:spPr>
+        <p:txBody>
+          <a:bodyPr wrap="square" anchor="t">
+            <a:spAutoFit/>
+          </a:bodyPr>
+          <a:lstStyle/>
+          <a:p>
+            <a:pPr algn="l"/>
+            <a:r>
+              <a:rPr sz="1100" b="0">
+                <a:solidFill>
+                  <a:srgbClr val="6E726A"/>
+                </a:solidFill>
+                <a:latin typeface="Helvetica Neue"/>
+              </a:rPr>
+              <a:t>Little Shared Library · shelf-scan · team review Oct 15</a:t>
+            </a:r>
+          </a:p>
+        </p:txBody>
+      </p:sp>
+      <p:sp>
+        <p:nvSpPr>
+          <p:cNvPr id="6" name="TextBox 5"/>
+          <p:cNvSpPr txBox="1"/>
+          <p:nvPr/>
+        </p:nvSpPr>
+        <p:spPr>
+          <a:xfrm>
+            <a:off x="10881360" y="6400800"/>
+            <a:ext cx="576072" cy="274320"/>
+          </a:xfrm>
+          <a:prstGeom prst="rect">
+            <a:avLst/>
+          </a:prstGeom>
+          <a:noFill/>
+        </p:spPr>
+        <p:txBody>
+          <a:bodyPr wrap="square" anchor="t">
+            <a:spAutoFit/>
+          </a:bodyPr>
+          <a:lstStyle/>
+          <a:p>
+            <a:pPr algn="r"/>
+            <a:r>
+              <a:rPr sz="1100" b="0">
+                <a:solidFill>
+                  <a:srgbClr val="6E726A"/>
+                </a:solidFill>
+                <a:latin typeface="Helvetica Neue"/>
+              </a:rPr>
+              <a:t>6</a:t>
             </a:r>
           </a:p>
         </p:txBody>
@@ -5236,7 +5609,7 @@
 </p:sld>
 </file>
 
-<file path=ppt/slides/slide6.xml><?xml version="1.0" encoding="utf-8"?>
+<file path=ppt/slides/slide7.xml><?xml version="1.0" encoding="utf-8"?>
 <p:sld xmlns:a="http://schemas.openxmlformats.org/drawingml/2006/main" xmlns:p="http://schemas.openxmlformats.org/presentationml/2006/main" xmlns:r="http://schemas.openxmlformats.org/officeDocument/2006/relationships">
   <p:cSld>
     <p:bg>
@@ -5442,7 +5815,7 @@
                 </a:solidFill>
                 <a:latin typeface="Helvetica Neue"/>
               </a:rPr>
-              <a:t>6</a:t>
+              <a:t>7</a:t>
             </a:r>
           </a:p>
         </p:txBody>

</xml_diff>